<commit_message>
EBITDA率を Y1:13% / Y2:18% / Y3-Y5:20% に修正
- EBITDAグラフ: [2260,7140,14880,27800,40000] → [1820,6480,14400,24000,40000]
- 年次PL表: 人件費・その他を各年再配分（家賃固定）
- EBITDA率: 16%/20%/21%/23%/20% → 13%/18%/20%/20%/20%
- Y3テキスト: EBITDA1.8億→1.4億に更新
</commit_message>
<xml_diff>
--- a/zen/07_融資・投資家資料/然グループ_統合ピッチデッキ_強化版.pptx
+++ b/zen/07_融資・投資家資料/然グループ_統合ピッチデッキ_強化版.pptx
@@ -10557,7 +10557,7 @@
                           </a:solidFill>
                           <a:latin typeface="IPAGothic"/>
                         </a:rPr>
-                        <a:t>▲3,500</a:t>
+                        <a:t>▲3,840</a:t>
                       </a:r>
                     </a:p>
                   </a:txBody>
@@ -10580,7 +10580,7 @@
                           </a:solidFill>
                           <a:latin typeface="IPAGothic"/>
                         </a:rPr>
-                        <a:t>▲8,500</a:t>
+                        <a:t>▲9,200</a:t>
                       </a:r>
                     </a:p>
                   </a:txBody>
@@ -10603,7 +10603,7 @@
                           </a:solidFill>
                           <a:latin typeface="IPAGothic"/>
                         </a:rPr>
-                        <a:t>▲16,000</a:t>
+                        <a:t>▲16,480</a:t>
                       </a:r>
                     </a:p>
                   </a:txBody>
@@ -10626,7 +10626,7 @@
                           </a:solidFill>
                           <a:latin typeface="IPAGothic"/>
                         </a:rPr>
-                        <a:t>▲26,000</a:t>
+                        <a:t>▲29,000</a:t>
                       </a:r>
                     </a:p>
                   </a:txBody>
@@ -10837,7 +10837,7 @@
                           </a:solidFill>
                           <a:latin typeface="IPAGothic"/>
                         </a:rPr>
-                        <a:t>▲2,400</a:t>
+                        <a:t>▲2,500</a:t>
                       </a:r>
                     </a:p>
                   </a:txBody>
@@ -10860,7 +10860,7 @@
                           </a:solidFill>
                           <a:latin typeface="IPAGothic"/>
                         </a:rPr>
-                        <a:t>▲5,600</a:t>
+                        <a:t>▲5,560</a:t>
                       </a:r>
                     </a:p>
                   </a:txBody>
@@ -10906,7 +10906,7 @@
                           </a:solidFill>
                           <a:latin typeface="IPAGothic"/>
                         </a:rPr>
-                        <a:t>▲18,000</a:t>
+                        <a:t>▲18,800</a:t>
                       </a:r>
                     </a:p>
                   </a:txBody>
@@ -10977,7 +10977,7 @@
                           </a:solidFill>
                           <a:latin typeface="IPAGothic"/>
                         </a:rPr>
-                        <a:t>2,260</a:t>
+                        <a:t>1,820</a:t>
                       </a:r>
                     </a:p>
                   </a:txBody>
@@ -11000,7 +11000,7 @@
                           </a:solidFill>
                           <a:latin typeface="IPAGothic"/>
                         </a:rPr>
-                        <a:t>7,140</a:t>
+                        <a:t>6,480</a:t>
                       </a:r>
                     </a:p>
                   </a:txBody>
@@ -11023,7 +11023,7 @@
                           </a:solidFill>
                           <a:latin typeface="IPAGothic"/>
                         </a:rPr>
-                        <a:t>14,880</a:t>
+                        <a:t>14,400</a:t>
                       </a:r>
                     </a:p>
                   </a:txBody>
@@ -11046,7 +11046,7 @@
                           </a:solidFill>
                           <a:latin typeface="IPAGothic"/>
                         </a:rPr>
-                        <a:t>27,800</a:t>
+                        <a:t>24,000</a:t>
                       </a:r>
                     </a:p>
                   </a:txBody>
@@ -11117,7 +11117,7 @@
                           </a:solidFill>
                           <a:latin typeface="IPAGothic"/>
                         </a:rPr>
-                        <a:t>16%</a:t>
+                        <a:t>13%</a:t>
                       </a:r>
                     </a:p>
                   </a:txBody>
@@ -11140,6 +11140,29 @@
                           </a:solidFill>
                           <a:latin typeface="IPAGothic"/>
                         </a:rPr>
+                        <a:t>18%</a:t>
+                      </a:r>
+                    </a:p>
+                  </a:txBody>
+                  <a:tcPr>
+                    <a:solidFill>
+                      <a:srgbClr val="F0EEE8"/>
+                    </a:solidFill>
+                  </a:tcPr>
+                </a:tc>
+                <a:tc>
+                  <a:txBody>
+                    <a:bodyPr/>
+                    <a:lstStyle/>
+                    <a:p>
+                      <a:pPr algn="ctr"/>
+                      <a:r>
+                        <a:rPr sz="1000" b="0">
+                          <a:solidFill>
+                            <a:srgbClr val="1A1A1A"/>
+                          </a:solidFill>
+                          <a:latin typeface="IPAGothic"/>
+                        </a:rPr>
                         <a:t>20%</a:t>
                       </a:r>
                     </a:p>
@@ -11163,30 +11186,7 @@
                           </a:solidFill>
                           <a:latin typeface="IPAGothic"/>
                         </a:rPr>
-                        <a:t>21%</a:t>
-                      </a:r>
-                    </a:p>
-                  </a:txBody>
-                  <a:tcPr>
-                    <a:solidFill>
-                      <a:srgbClr val="F0EEE8"/>
-                    </a:solidFill>
-                  </a:tcPr>
-                </a:tc>
-                <a:tc>
-                  <a:txBody>
-                    <a:bodyPr/>
-                    <a:lstStyle/>
-                    <a:p>
-                      <a:pPr algn="ctr"/>
-                      <a:r>
-                        <a:rPr sz="1000" b="0">
-                          <a:solidFill>
-                            <a:srgbClr val="1A1A1A"/>
-                          </a:solidFill>
-                          <a:latin typeface="IPAGothic"/>
-                        </a:rPr>
-                        <a:t>23%</a:t>
+                        <a:t>20%</a:t>
                       </a:r>
                     </a:p>
                   </a:txBody>
@@ -13545,7 +13545,7 @@
                 </a:solidFill>
                 <a:latin typeface="IPAGothic"/>
               </a:rPr>
-              <a:t>・Y3以降：FCスケールで利益率が改善。EBITDA1.8億円（月商6,000万）で成長が加速</a:t>
+              <a:t>・Y3以降：FCスケールで利益率が20%に安定。EBITDA1.4億円（月商6,000万）で成長が加速</a:t>
             </a:r>
           </a:p>
           <a:p>

</xml_diff>